<commit_message>
Reconcile 250-user collateral to new scores; delete the 50-user study
- Doc builders updated to the re-derived composite scores (USR-118 51.7 #1,
  USR-156 46.2 #2, USR-234 20.0 #7, USR-042 12.9 #30) and catch-all-four FP
  8.1% -> 10.6%; per-phase score tables overwritten to authoritative values.
- Refreshed data/tier3_results/composite_scores.csv (dynamic-table source) and
  regenerated the builders that read it live.
- Deleted the separate 50-user / 130-day / 19-week study (build_analysis_doc.py,
  build_analysis_deck.py, build_technical_deck.py + their outputs) and stripped
  the dangling 50-user AUC footnotes — all collateral is now 250-user only.
- Demo-video builders intentionally untouched.

Co-Authored-By: Claude Opus 4.8 <noreply@anthropic.com>
</commit_message>
<xml_diff>
--- a/WP DLA/Presentation/Pentagon_Working_Session_Deck.pptx
+++ b/WP DLA/Presentation/Pentagon_Working_Session_Deck.pptx
@@ -8577,7 +8577,7 @@
                 </a:solidFill>
                 <a:latin typeface="Consolas"/>
               </a:rPr>
-              <a:t>Volt:   6.40 + 5.50 + 1.14 + 0.23 + 0.43 + 0.00  =  13.70   (rank #24, stealthiest)</a:t>
+              <a:t>Volt:   6.20 + 5.00 + 1.11 + 0.20 + 0.42 + 0.00  =  12.93   (rank #30, stealthiest)</a:t>
             </a:r>
           </a:p>
           <a:p>
@@ -8589,7 +8589,7 @@
                 </a:solidFill>
                 <a:latin typeface="Consolas"/>
               </a:rPr>
-              <a:t>Salt:  29.89 + 9.00 + 2.87 + 4.32 + 2.39 + 2.80  =  51.27   (rank #1)</a:t>
+              <a:t>Salt:  30.60 + 8.50 + 2.88 + 4.50 + 2.43 + 2.80  =  51.71   (rank #1)</a:t>
             </a:r>
           </a:p>
         </p:txBody>
@@ -9078,7 +9078,7 @@
                         <a:rPr sz="1200">
                           <a:latin typeface="Segoe UI"/>
                         </a:rPr>
-                        <a:t>29.89</a:t>
+                        <a:t>30.60</a:t>
                       </a:r>
                     </a:p>
                   </a:txBody>
@@ -9093,7 +9093,7 @@
                         <a:rPr sz="1200">
                           <a:latin typeface="Segoe UI"/>
                         </a:rPr>
-                        <a:t>18</a:t>
+                        <a:t>17</a:t>
                       </a:r>
                     </a:p>
                   </a:txBody>
@@ -9123,7 +9123,7 @@
                         <a:rPr sz="1200">
                           <a:latin typeface="Segoe UI"/>
                         </a:rPr>
-                        <a:t>8.65 / 7.94</a:t>
+                        <a:t>9.00 / 8.10</a:t>
                       </a:r>
                     </a:p>
                   </a:txBody>
@@ -9153,7 +9153,7 @@
                         <a:rPr sz="1200">
                           <a:latin typeface="Segoe UI"/>
                         </a:rPr>
-                        <a:t>51.27 (#1)</a:t>
+                        <a:t>51.71 (#1)</a:t>
                       </a:r>
                     </a:p>
                   </a:txBody>
@@ -9292,7 +9292,7 @@
                         <a:rPr sz="1200">
                           <a:latin typeface="Segoe UI"/>
                         </a:rPr>
-                        <a:t>4.47</a:t>
+                        <a:t>4.50</a:t>
                       </a:r>
                     </a:p>
                   </a:txBody>
@@ -9307,7 +9307,7 @@
                         <a:rPr sz="1200">
                           <a:latin typeface="Segoe UI"/>
                         </a:rPr>
-                        <a:t>1</a:t>
+                        <a:t>2</a:t>
                       </a:r>
                     </a:p>
                   </a:txBody>
@@ -9367,7 +9367,7 @@
                         <a:rPr sz="1200">
                           <a:latin typeface="Segoe UI"/>
                         </a:rPr>
-                        <a:t>19.44 (#7)</a:t>
+                        <a:t>20.00 (#7)</a:t>
                       </a:r>
                     </a:p>
                   </a:txBody>
@@ -9399,7 +9399,7 @@
                         <a:rPr sz="1200">
                           <a:latin typeface="Segoe UI"/>
                         </a:rPr>
-                        <a:t>6.40</a:t>
+                        <a:t>6.20</a:t>
                       </a:r>
                     </a:p>
                   </a:txBody>
@@ -9414,7 +9414,7 @@
                         <a:rPr sz="1200">
                           <a:latin typeface="Segoe UI"/>
                         </a:rPr>
-                        <a:t>11</a:t>
+                        <a:t>10</a:t>
                       </a:r>
                     </a:p>
                   </a:txBody>
@@ -9429,7 +9429,7 @@
                         <a:rPr sz="1200">
                           <a:latin typeface="Segoe UI"/>
                         </a:rPr>
-                        <a:t>3.80</a:t>
+                        <a:t>3.70</a:t>
                       </a:r>
                     </a:p>
                   </a:txBody>
@@ -9444,7 +9444,7 @@
                         <a:rPr sz="1200">
                           <a:latin typeface="Segoe UI"/>
                         </a:rPr>
-                        <a:t>0.47 / 1.43</a:t>
+                        <a:t>0.40 / 1.40</a:t>
                       </a:r>
                     </a:p>
                   </a:txBody>
@@ -9474,7 +9474,7 @@
                         <a:rPr sz="1200">
                           <a:latin typeface="Segoe UI"/>
                         </a:rPr>
-                        <a:t>13.70 (#24)</a:t>
+                        <a:t>12.90 (#30)</a:t>
                       </a:r>
                     </a:p>
                   </a:txBody>
@@ -9515,7 +9515,7 @@
                 </a:solidFill>
                 <a:latin typeface="Segoe UI"/>
               </a:rPr>
-              <a:t>Read it: Slow APT is invisible on every magnitude column (signal 4.47, breadth 1) and is caught by novelty ALONE (13.0, a novel C2 IP every week for 60 weeks). Volt has breadth (11) of small signals and no novelty: the living-off-the-land signature. No single number flags either; the twin separates them by the full picture.</a:t>
+              <a:t>Read it: Slow APT is invisible on every magnitude column (signal 4.50, breadth 2) and is caught by novelty ALONE (13.0, a novel C2 IP every week for 60 weeks). Volt has breadth (10) of small signals and no novelty: the living-off-the-land signature. No single number flags either; the twin separates them by the full picture.</a:t>
             </a:r>
           </a:p>
         </p:txBody>
@@ -9761,7 +9761,7 @@
                 </a:solidFill>
                 <a:latin typeface="Segoe UI"/>
               </a:rPr>
-              <a:t>Unsupervised, by rank: 4 of 4 surfaced at an 8.1% operating point</a:t>
+              <a:t>Unsupervised, by rank: 4 of 4 surfaced at a 10.6% operating point</a:t>
             </a:r>
           </a:p>
         </p:txBody>
@@ -9989,7 +9989,7 @@
                 </a:solidFill>
                 <a:latin typeface="Segoe UI"/>
               </a:rPr>
-              <a:t>51.27</a:t>
+              <a:t>51.71</a:t>
             </a:r>
           </a:p>
         </p:txBody>
@@ -10199,7 +10199,7 @@
                 </a:solidFill>
                 <a:latin typeface="Segoe UI"/>
               </a:rPr>
-              <a:t>19.44</a:t>
+              <a:t>20.00</a:t>
             </a:r>
           </a:p>
         </p:txBody>
@@ -10269,7 +10269,7 @@
                 </a:solidFill>
                 <a:latin typeface="Segoe UI"/>
               </a:rPr>
-              <a:t>#24</a:t>
+              <a:t>#30</a:t>
             </a:r>
           </a:p>
         </p:txBody>
@@ -10304,7 +10304,7 @@
                 </a:solidFill>
                 <a:latin typeface="Segoe UI"/>
               </a:rPr>
-              <a:t>13.70</a:t>
+              <a:t>12.90</a:t>
             </a:r>
           </a:p>
         </p:txBody>
@@ -10418,7 +10418,7 @@
                 </a:solidFill>
                 <a:latin typeface="Segoe UI"/>
               </a:rPr>
-              <a:t>surfaced by rank at an 8.1% operating point (value is coverage + MITRE direction)</a:t>
+              <a:t>surfaced by rank at a 10.6% operating point (value is coverage + MITRE direction)</a:t>
             </a:r>
           </a:p>
         </p:txBody>
@@ -10901,7 +10901,7 @@
                 </a:solidFill>
                 <a:latin typeface="Segoe UI"/>
               </a:rPr>
-              <a:t>Signal strength 4.47, breadth 1: invisible to every magnitude method. Caught by novelty alone, a novel command-and-control IP recurring every week for 60 weeks. That one signal lifts it to rank #7.</a:t>
+              <a:t>Signal strength 4.50, breadth 2: invisible to every magnitude method. Caught by novelty alone, a novel command-and-control IP recurring every week for 60 weeks. That one signal lifts it to rank #7.</a:t>
             </a:r>
           </a:p>
         </p:txBody>
@@ -15962,7 +15962,7 @@
                 </a:solidFill>
                 <a:latin typeface="Segoe UI"/>
               </a:rPr>
-              <a:t>Measured detection fidelity: 4 of 4 at 8.1% where classical methods catch 0 of 4, on the logs she already has.</a:t>
+              <a:t>Measured detection fidelity: 4 of 4 at 10.6% where classical methods catch 0 of 4, on the logs she already has.</a:t>
             </a:r>
           </a:p>
         </p:txBody>
@@ -16658,7 +16658,7 @@
                 </a:solidFill>
                 <a:latin typeface="Segoe UI"/>
               </a:rPr>
-              <a:t>• Production (threat-profile detector): 4 of 4 at 0 false positives, by named fingerprint. Discovery (twin): 4 of 4 by rank at 8.1% FP; classical baselines 0 of 4, z-score 1 of 4.</a:t>
+              <a:t>• Production (threat-profile detector): 4 of 4 at 0 false positives, by named fingerprint. Discovery (twin): 4 of 4 by rank at 10.6% FP; classical baselines 0 of 4, z-score 1 of 4.</a:t>
             </a:r>
           </a:p>
           <a:p>
@@ -16674,7 +16674,7 @@
                 </a:solidFill>
                 <a:latin typeface="Segoe UI"/>
               </a:rPr>
-              <a:t>• Ranks: Salt #1 (51.27), Insider #2 (46.24), Slow APT #7 (19.44), Volt #24 (13.70).</a:t>
+              <a:t>• Ranks: Salt #1 (51.71), Insider #2 (46.24), Slow APT #7 (20.00), Volt #30 (12.90).</a:t>
             </a:r>
           </a:p>
           <a:p>

</xml_diff>